<commit_message>
Product Details - Show dynamic contents at details page (part - 1)
</commit_message>
<xml_diff>
--- a/.lessons/61 Flash Sale Feature/7 Flash Sale- Show products at flash sale page/1.pptx
+++ b/.lessons/61 Flash Sale Feature/7 Flash Sale- Show products at flash sale page/1.pptx
@@ -20,6 +20,10 @@
     <p:sldId id="428" r:id="rId14"/>
     <p:sldId id="429" r:id="rId15"/>
     <p:sldId id="419" r:id="rId16"/>
+    <p:sldId id="430" r:id="rId17"/>
+    <p:sldId id="431" r:id="rId18"/>
+    <p:sldId id="432" r:id="rId19"/>
+    <p:sldId id="434" r:id="rId20"/>
   </p:sldIdLst>
   <p:sldSz cx="12192000" cy="6858000"/>
   <p:notesSz cx="6858000" cy="9144000"/>
@@ -3813,7 +3817,7 @@
         <p:spPr>
           <a:xfrm>
             <a:off x="0" y="0"/>
-            <a:ext cx="12192000" cy="355354"/>
+            <a:ext cx="12192000" cy="4256422"/>
           </a:xfrm>
           <a:prstGeom prst="rect">
             <a:avLst/>
@@ -3833,7 +3837,13 @@
               <a:buNone/>
             </a:pPr>
             <a:r>
-              <a:rPr kumimoji="0" lang="en-US" altLang="en-US" sz="1300" b="0" i="0" u="none" strike="noStrike" cap="none" normalizeH="0" baseline="0">
+              <a:rPr lang="az-Latn-AZ" altLang="en-US" sz="1300">
+                <a:latin typeface="Arial" panose="020B0604020202020204" pitchFamily="34" charset="0"/>
+              </a:rPr>
+              <a:t>Ə</a:t>
+            </a:r>
+            <a:r>
+              <a:rPr kumimoji="0" lang="az-Latn-AZ" altLang="en-US" sz="1300" b="0" i="0" u="none" strike="noStrike" cap="none" normalizeH="0" baseline="0">
                 <a:ln>
                   <a:noFill/>
                 </a:ln>
@@ -3843,11 +3853,330 @@
                 <a:effectLst/>
                 <a:latin typeface="Arial" panose="020B0604020202020204" pitchFamily="34" charset="0"/>
               </a:rPr>
-              <a:t>.</a:t>
-            </a:r>
-          </a:p>
-        </p:txBody>
-      </p:sp>
+              <a:t>gər əlavə etsəniz bu forma pagi</a:t>
+            </a:r>
+            <a:r>
+              <a:rPr lang="az-Latn-AZ" altLang="en-US" sz="1300">
+                <a:latin typeface="Arial" panose="020B0604020202020204" pitchFamily="34" charset="0"/>
+              </a:rPr>
+              <a:t>nation -lar görməlisiniz. İstəsəz CSS ilə dizayn verərək pagionation -ların formasını dəyişdirə bilərsiniz.</a:t>
+            </a:r>
+          </a:p>
+          <a:p>
+            <a:pPr>
+              <a:lnSpc>
+                <a:spcPct val="150000"/>
+              </a:lnSpc>
+              <a:buNone/>
+            </a:pPr>
+            <a:endParaRPr kumimoji="0" lang="az-Latn-AZ" altLang="en-US" sz="1300" b="0" i="0" u="none" strike="noStrike" cap="none" normalizeH="0" baseline="0">
+              <a:ln>
+                <a:noFill/>
+              </a:ln>
+              <a:solidFill>
+                <a:schemeClr val="tx1"/>
+              </a:solidFill>
+              <a:effectLst/>
+              <a:latin typeface="Arial" panose="020B0604020202020204" pitchFamily="34" charset="0"/>
+            </a:endParaRPr>
+          </a:p>
+          <a:p>
+            <a:pPr>
+              <a:lnSpc>
+                <a:spcPct val="150000"/>
+              </a:lnSpc>
+              <a:buNone/>
+            </a:pPr>
+            <a:endParaRPr lang="az-Latn-AZ" altLang="en-US" sz="1300">
+              <a:latin typeface="Arial" panose="020B0604020202020204" pitchFamily="34" charset="0"/>
+            </a:endParaRPr>
+          </a:p>
+          <a:p>
+            <a:pPr>
+              <a:lnSpc>
+                <a:spcPct val="150000"/>
+              </a:lnSpc>
+              <a:buNone/>
+            </a:pPr>
+            <a:endParaRPr kumimoji="0" lang="az-Latn-AZ" altLang="en-US" sz="1300" b="0" i="0" u="none" strike="noStrike" cap="none" normalizeH="0" baseline="0">
+              <a:ln>
+                <a:noFill/>
+              </a:ln>
+              <a:solidFill>
+                <a:schemeClr val="tx1"/>
+              </a:solidFill>
+              <a:effectLst/>
+              <a:latin typeface="Arial" panose="020B0604020202020204" pitchFamily="34" charset="0"/>
+            </a:endParaRPr>
+          </a:p>
+          <a:p>
+            <a:pPr>
+              <a:lnSpc>
+                <a:spcPct val="150000"/>
+              </a:lnSpc>
+              <a:buNone/>
+            </a:pPr>
+            <a:endParaRPr lang="az-Latn-AZ" altLang="en-US" sz="1300">
+              <a:latin typeface="Arial" panose="020B0604020202020204" pitchFamily="34" charset="0"/>
+            </a:endParaRPr>
+          </a:p>
+          <a:p>
+            <a:pPr>
+              <a:lnSpc>
+                <a:spcPct val="150000"/>
+              </a:lnSpc>
+              <a:buNone/>
+            </a:pPr>
+            <a:endParaRPr kumimoji="0" lang="az-Latn-AZ" altLang="en-US" sz="1300" b="0" i="0" u="none" strike="noStrike" cap="none" normalizeH="0" baseline="0">
+              <a:ln>
+                <a:noFill/>
+              </a:ln>
+              <a:solidFill>
+                <a:schemeClr val="tx1"/>
+              </a:solidFill>
+              <a:effectLst/>
+              <a:latin typeface="Arial" panose="020B0604020202020204" pitchFamily="34" charset="0"/>
+            </a:endParaRPr>
+          </a:p>
+          <a:p>
+            <a:pPr>
+              <a:lnSpc>
+                <a:spcPct val="150000"/>
+              </a:lnSpc>
+              <a:buNone/>
+            </a:pPr>
+            <a:endParaRPr lang="az-Latn-AZ" altLang="en-US" sz="1300">
+              <a:latin typeface="Arial" panose="020B0604020202020204" pitchFamily="34" charset="0"/>
+            </a:endParaRPr>
+          </a:p>
+          <a:p>
+            <a:pPr>
+              <a:lnSpc>
+                <a:spcPct val="150000"/>
+              </a:lnSpc>
+              <a:buNone/>
+            </a:pPr>
+            <a:endParaRPr kumimoji="0" lang="az-Latn-AZ" altLang="en-US" sz="1300" b="0" i="0" u="none" strike="noStrike" cap="none" normalizeH="0" baseline="0">
+              <a:ln>
+                <a:noFill/>
+              </a:ln>
+              <a:solidFill>
+                <a:schemeClr val="tx1"/>
+              </a:solidFill>
+              <a:effectLst/>
+              <a:latin typeface="Arial" panose="020B0604020202020204" pitchFamily="34" charset="0"/>
+            </a:endParaRPr>
+          </a:p>
+          <a:p>
+            <a:pPr>
+              <a:lnSpc>
+                <a:spcPct val="150000"/>
+              </a:lnSpc>
+              <a:buNone/>
+            </a:pPr>
+            <a:endParaRPr lang="az-Latn-AZ" altLang="en-US" sz="1300">
+              <a:latin typeface="Arial" panose="020B0604020202020204" pitchFamily="34" charset="0"/>
+            </a:endParaRPr>
+          </a:p>
+          <a:p>
+            <a:pPr>
+              <a:lnSpc>
+                <a:spcPct val="150000"/>
+              </a:lnSpc>
+              <a:buNone/>
+            </a:pPr>
+            <a:endParaRPr kumimoji="0" lang="az-Latn-AZ" altLang="en-US" sz="1300" b="0" i="0" u="none" strike="noStrike" cap="none" normalizeH="0" baseline="0">
+              <a:ln>
+                <a:noFill/>
+              </a:ln>
+              <a:solidFill>
+                <a:schemeClr val="tx1"/>
+              </a:solidFill>
+              <a:effectLst/>
+              <a:latin typeface="Arial" panose="020B0604020202020204" pitchFamily="34" charset="0"/>
+            </a:endParaRPr>
+          </a:p>
+          <a:p>
+            <a:pPr>
+              <a:lnSpc>
+                <a:spcPct val="150000"/>
+              </a:lnSpc>
+              <a:buNone/>
+            </a:pPr>
+            <a:endParaRPr lang="az-Latn-AZ" altLang="en-US" sz="1300">
+              <a:latin typeface="Arial" panose="020B0604020202020204" pitchFamily="34" charset="0"/>
+            </a:endParaRPr>
+          </a:p>
+          <a:p>
+            <a:pPr>
+              <a:lnSpc>
+                <a:spcPct val="150000"/>
+              </a:lnSpc>
+              <a:buNone/>
+            </a:pPr>
+            <a:endParaRPr kumimoji="0" lang="az-Latn-AZ" altLang="en-US" sz="1300" b="0" i="0" u="none" strike="noStrike" cap="none" normalizeH="0" baseline="0">
+              <a:ln>
+                <a:noFill/>
+              </a:ln>
+              <a:solidFill>
+                <a:schemeClr val="tx1"/>
+              </a:solidFill>
+              <a:effectLst/>
+              <a:latin typeface="Arial" panose="020B0604020202020204" pitchFamily="34" charset="0"/>
+            </a:endParaRPr>
+          </a:p>
+          <a:p>
+            <a:pPr>
+              <a:lnSpc>
+                <a:spcPct val="150000"/>
+              </a:lnSpc>
+              <a:buNone/>
+            </a:pPr>
+            <a:endParaRPr lang="az-Latn-AZ" altLang="en-US" sz="1300">
+              <a:latin typeface="Arial" panose="020B0604020202020204" pitchFamily="34" charset="0"/>
+            </a:endParaRPr>
+          </a:p>
+          <a:p>
+            <a:pPr>
+              <a:lnSpc>
+                <a:spcPct val="150000"/>
+              </a:lnSpc>
+              <a:buNone/>
+            </a:pPr>
+            <a:r>
+              <a:rPr kumimoji="0" lang="az-Latn-AZ" altLang="en-US" sz="1300" b="0" i="0" u="none" strike="noStrike" cap="none" normalizeH="0" baseline="0">
+                <a:ln>
+                  <a:noFill/>
+                </a:ln>
+                <a:solidFill>
+                  <a:schemeClr val="tx1"/>
+                </a:solidFill>
+                <a:effectLst/>
+                <a:latin typeface="Arial" panose="020B0604020202020204" pitchFamily="34" charset="0"/>
+              </a:rPr>
+              <a:t>Məsələn y</a:t>
+            </a:r>
+            <a:r>
+              <a:rPr lang="az-Latn-AZ" altLang="en-US" sz="1300">
+                <a:latin typeface="Arial" panose="020B0604020202020204" pitchFamily="34" charset="0"/>
+              </a:rPr>
+              <a:t>umru: </a:t>
+            </a:r>
+            <a:endParaRPr kumimoji="0" lang="en-US" altLang="en-US" sz="1300" b="0" i="0" u="none" strike="noStrike" cap="none" normalizeH="0" baseline="0">
+              <a:ln>
+                <a:noFill/>
+              </a:ln>
+              <a:solidFill>
+                <a:schemeClr val="tx1"/>
+              </a:solidFill>
+              <a:effectLst/>
+              <a:latin typeface="Arial" panose="020B0604020202020204" pitchFamily="34" charset="0"/>
+            </a:endParaRPr>
+          </a:p>
+        </p:txBody>
+      </p:sp>
+      <p:pic>
+        <p:nvPicPr>
+          <p:cNvPr id="4" name="Picture 3">
+            <a:extLst>
+              <a:ext uri="{FF2B5EF4-FFF2-40B4-BE49-F238E27FC236}">
+                <a16:creationId xmlns:a16="http://schemas.microsoft.com/office/drawing/2014/main" id="{6C97FE13-7901-79B2-9342-EE294187A253}"/>
+              </a:ext>
+            </a:extLst>
+          </p:cNvPr>
+          <p:cNvPicPr>
+            <a:picLocks noChangeAspect="1"/>
+          </p:cNvPicPr>
+          <p:nvPr/>
+        </p:nvPicPr>
+        <p:blipFill>
+          <a:blip r:embed="rId2">
+            <a:extLst>
+              <a:ext uri="{28A0092B-C50C-407E-A947-70E740481C1C}">
+                <a14:useLocalDpi xmlns:a14="http://schemas.microsoft.com/office/drawing/2010/main" val="0"/>
+              </a:ext>
+            </a:extLst>
+          </a:blip>
+          <a:stretch>
+            <a:fillRect/>
+          </a:stretch>
+        </p:blipFill>
+        <p:spPr>
+          <a:xfrm>
+            <a:off x="162357" y="621867"/>
+            <a:ext cx="9096375" cy="2695575"/>
+          </a:xfrm>
+          <a:prstGeom prst="rect">
+            <a:avLst/>
+          </a:prstGeom>
+          <a:solidFill>
+            <a:srgbClr val="FFFFFF">
+              <a:shade val="85000"/>
+            </a:srgbClr>
+          </a:solidFill>
+          <a:ln w="88900" cap="sq">
+            <a:solidFill>
+              <a:srgbClr val="FFFFFF"/>
+            </a:solidFill>
+            <a:miter lim="800000"/>
+          </a:ln>
+          <a:effectLst>
+            <a:outerShdw blurRad="55000" dist="18000" dir="5400000" algn="tl" rotWithShape="0">
+              <a:srgbClr val="000000">
+                <a:alpha val="40000"/>
+              </a:srgbClr>
+            </a:outerShdw>
+          </a:effectLst>
+          <a:scene3d>
+            <a:camera prst="orthographicFront"/>
+            <a:lightRig rig="twoPt" dir="t">
+              <a:rot lat="0" lon="0" rev="7200000"/>
+            </a:lightRig>
+          </a:scene3d>
+          <a:sp3d>
+            <a:bevelT w="25400" h="19050"/>
+            <a:contourClr>
+              <a:srgbClr val="FFFFFF"/>
+            </a:contourClr>
+          </a:sp3d>
+        </p:spPr>
+      </p:pic>
+      <p:pic>
+        <p:nvPicPr>
+          <p:cNvPr id="6" name="Picture 5">
+            <a:extLst>
+              <a:ext uri="{FF2B5EF4-FFF2-40B4-BE49-F238E27FC236}">
+                <a16:creationId xmlns:a16="http://schemas.microsoft.com/office/drawing/2014/main" id="{78034B3A-D1C2-31E2-8340-B607F9CB638D}"/>
+              </a:ext>
+            </a:extLst>
+          </p:cNvPr>
+          <p:cNvPicPr>
+            <a:picLocks noChangeAspect="1"/>
+          </p:cNvPicPr>
+          <p:nvPr/>
+        </p:nvPicPr>
+        <p:blipFill>
+          <a:blip r:embed="rId3">
+            <a:extLst>
+              <a:ext uri="{28A0092B-C50C-407E-A947-70E740481C1C}">
+                <a14:useLocalDpi xmlns:a14="http://schemas.microsoft.com/office/drawing/2010/main" val="0"/>
+              </a:ext>
+            </a:extLst>
+          </a:blip>
+          <a:stretch>
+            <a:fillRect/>
+          </a:stretch>
+        </p:blipFill>
+        <p:spPr>
+          <a:xfrm>
+            <a:off x="0" y="4425874"/>
+            <a:ext cx="2609850" cy="600075"/>
+          </a:xfrm>
+          <a:prstGeom prst="rect">
+            <a:avLst/>
+          </a:prstGeom>
+        </p:spPr>
+      </p:pic>
     </p:spTree>
     <p:extLst>
       <p:ext uri="{BB962C8B-B14F-4D97-AF65-F5344CB8AC3E}">
@@ -3919,21 +4248,66 @@
               <a:buNone/>
             </a:pPr>
             <a:r>
-              <a:rPr kumimoji="0" lang="en-US" altLang="en-US" sz="1300" b="0" i="0" u="none" strike="noStrike" cap="none" normalizeH="0" baseline="0">
-                <a:ln>
-                  <a:noFill/>
-                </a:ln>
-                <a:solidFill>
-                  <a:schemeClr val="tx1"/>
-                </a:solidFill>
-                <a:effectLst/>
+              <a:rPr lang="az-Latn-AZ" altLang="en-US" sz="1300">
                 <a:latin typeface="Arial" panose="020B0604020202020204" pitchFamily="34" charset="0"/>
               </a:rPr>
-              <a:t>.</a:t>
-            </a:r>
-          </a:p>
-        </p:txBody>
-      </p:sp>
+              <a:t>Yumru forma</a:t>
+            </a:r>
+            <a:r>
+              <a:rPr lang="en-US" altLang="en-US" sz="1300">
+                <a:latin typeface="Arial" panose="020B0604020202020204" pitchFamily="34" charset="0"/>
+              </a:rPr>
+              <a:t>da olan</a:t>
+            </a:r>
+            <a:r>
+              <a:rPr lang="az-Latn-AZ" altLang="en-US" sz="1300">
+                <a:latin typeface="Arial" panose="020B0604020202020204" pitchFamily="34" charset="0"/>
+              </a:rPr>
+              <a:t> pagination əldə etmək üçün, CSS stillərini şəkildəki kimi yazırıq.</a:t>
+            </a:r>
+            <a:endParaRPr kumimoji="0" lang="en-US" altLang="en-US" sz="1300" b="0" i="0" u="none" strike="noStrike" cap="none" normalizeH="0" baseline="0">
+              <a:ln>
+                <a:noFill/>
+              </a:ln>
+              <a:solidFill>
+                <a:schemeClr val="tx1"/>
+              </a:solidFill>
+              <a:effectLst/>
+              <a:latin typeface="Arial" panose="020B0604020202020204" pitchFamily="34" charset="0"/>
+            </a:endParaRPr>
+          </a:p>
+        </p:txBody>
+      </p:sp>
+      <p:pic>
+        <p:nvPicPr>
+          <p:cNvPr id="4" name="Picture 3">
+            <a:extLst>
+              <a:ext uri="{FF2B5EF4-FFF2-40B4-BE49-F238E27FC236}">
+                <a16:creationId xmlns:a16="http://schemas.microsoft.com/office/drawing/2014/main" id="{3B90A3B4-8636-127B-D424-F14C71F1A5BC}"/>
+              </a:ext>
+            </a:extLst>
+          </p:cNvPr>
+          <p:cNvPicPr>
+            <a:picLocks noChangeAspect="1"/>
+          </p:cNvPicPr>
+          <p:nvPr/>
+        </p:nvPicPr>
+        <p:blipFill>
+          <a:blip r:embed="rId2"/>
+          <a:stretch>
+            <a:fillRect/>
+          </a:stretch>
+        </p:blipFill>
+        <p:spPr>
+          <a:xfrm>
+            <a:off x="8091125" y="0"/>
+            <a:ext cx="4100875" cy="6858000"/>
+          </a:xfrm>
+          <a:prstGeom prst="rect">
+            <a:avLst/>
+          </a:prstGeom>
+        </p:spPr>
+      </p:pic>
     </p:spTree>
     <p:extLst>
       <p:ext uri="{BB962C8B-B14F-4D97-AF65-F5344CB8AC3E}">
@@ -4020,6 +4394,66 @@
           </a:p>
         </p:txBody>
       </p:sp>
+      <p:pic>
+        <p:nvPicPr>
+          <p:cNvPr id="4" name="Picture 3">
+            <a:extLst>
+              <a:ext uri="{FF2B5EF4-FFF2-40B4-BE49-F238E27FC236}">
+                <a16:creationId xmlns:a16="http://schemas.microsoft.com/office/drawing/2014/main" id="{DFBA94C1-604B-5A0C-D1BD-FB0935A502E7}"/>
+              </a:ext>
+            </a:extLst>
+          </p:cNvPr>
+          <p:cNvPicPr>
+            <a:picLocks noChangeAspect="1"/>
+          </p:cNvPicPr>
+          <p:nvPr/>
+        </p:nvPicPr>
+        <p:blipFill>
+          <a:blip r:embed="rId2"/>
+          <a:stretch>
+            <a:fillRect/>
+          </a:stretch>
+        </p:blipFill>
+        <p:spPr>
+          <a:xfrm>
+            <a:off x="2860729" y="0"/>
+            <a:ext cx="6470542" cy="6858000"/>
+          </a:xfrm>
+          <a:prstGeom prst="rect">
+            <a:avLst/>
+          </a:prstGeom>
+          <a:solidFill>
+            <a:srgbClr val="FFFFFF">
+              <a:shade val="85000"/>
+            </a:srgbClr>
+          </a:solidFill>
+          <a:ln w="88900" cap="sq">
+            <a:solidFill>
+              <a:srgbClr val="FFFFFF"/>
+            </a:solidFill>
+            <a:miter lim="800000"/>
+          </a:ln>
+          <a:effectLst>
+            <a:outerShdw blurRad="55000" dist="18000" dir="5400000" algn="tl" rotWithShape="0">
+              <a:srgbClr val="000000">
+                <a:alpha val="40000"/>
+              </a:srgbClr>
+            </a:outerShdw>
+          </a:effectLst>
+          <a:scene3d>
+            <a:camera prst="orthographicFront"/>
+            <a:lightRig rig="twoPt" dir="t">
+              <a:rot lat="0" lon="0" rev="7200000"/>
+            </a:lightRig>
+          </a:scene3d>
+          <a:sp3d>
+            <a:bevelT w="25400" h="19050"/>
+            <a:contourClr>
+              <a:srgbClr val="FFFFFF"/>
+            </a:contourClr>
+          </a:sp3d>
+        </p:spPr>
+      </p:pic>
     </p:spTree>
     <p:extLst>
       <p:ext uri="{BB962C8B-B14F-4D97-AF65-F5344CB8AC3E}">
@@ -4106,6 +4540,66 @@
           </a:p>
         </p:txBody>
       </p:sp>
+      <p:pic>
+        <p:nvPicPr>
+          <p:cNvPr id="4" name="Picture 3">
+            <a:extLst>
+              <a:ext uri="{FF2B5EF4-FFF2-40B4-BE49-F238E27FC236}">
+                <a16:creationId xmlns:a16="http://schemas.microsoft.com/office/drawing/2014/main" id="{38D215B6-ACB9-CE04-7CEA-E41F49BBEAD5}"/>
+              </a:ext>
+            </a:extLst>
+          </p:cNvPr>
+          <p:cNvPicPr>
+            <a:picLocks noChangeAspect="1"/>
+          </p:cNvPicPr>
+          <p:nvPr/>
+        </p:nvPicPr>
+        <p:blipFill>
+          <a:blip r:embed="rId2"/>
+          <a:stretch>
+            <a:fillRect/>
+          </a:stretch>
+        </p:blipFill>
+        <p:spPr>
+          <a:xfrm>
+            <a:off x="0" y="84589"/>
+            <a:ext cx="12192000" cy="6688822"/>
+          </a:xfrm>
+          <a:prstGeom prst="rect">
+            <a:avLst/>
+          </a:prstGeom>
+          <a:solidFill>
+            <a:srgbClr val="FFFFFF">
+              <a:shade val="85000"/>
+            </a:srgbClr>
+          </a:solidFill>
+          <a:ln w="88900" cap="sq">
+            <a:solidFill>
+              <a:srgbClr val="FFFFFF"/>
+            </a:solidFill>
+            <a:miter lim="800000"/>
+          </a:ln>
+          <a:effectLst>
+            <a:outerShdw blurRad="55000" dist="18000" dir="5400000" algn="tl" rotWithShape="0">
+              <a:srgbClr val="000000">
+                <a:alpha val="40000"/>
+              </a:srgbClr>
+            </a:outerShdw>
+          </a:effectLst>
+          <a:scene3d>
+            <a:camera prst="orthographicFront"/>
+            <a:lightRig rig="twoPt" dir="t">
+              <a:rot lat="0" lon="0" rev="7200000"/>
+            </a:lightRig>
+          </a:scene3d>
+          <a:sp3d>
+            <a:bevelT w="25400" h="19050"/>
+            <a:contourClr>
+              <a:srgbClr val="FFFFFF"/>
+            </a:contourClr>
+          </a:sp3d>
+        </p:spPr>
+      </p:pic>
     </p:spTree>
     <p:extLst>
       <p:ext uri="{BB962C8B-B14F-4D97-AF65-F5344CB8AC3E}">
@@ -4192,10 +4686,504 @@
           </a:p>
         </p:txBody>
       </p:sp>
+      <p:pic>
+        <p:nvPicPr>
+          <p:cNvPr id="4" name="Picture 3">
+            <a:extLst>
+              <a:ext uri="{FF2B5EF4-FFF2-40B4-BE49-F238E27FC236}">
+                <a16:creationId xmlns:a16="http://schemas.microsoft.com/office/drawing/2014/main" id="{22E0C896-AF86-3E0C-F4DB-D9F797EE18AF}"/>
+              </a:ext>
+            </a:extLst>
+          </p:cNvPr>
+          <p:cNvPicPr>
+            <a:picLocks noChangeAspect="1"/>
+          </p:cNvPicPr>
+          <p:nvPr/>
+        </p:nvPicPr>
+        <p:blipFill>
+          <a:blip r:embed="rId2"/>
+          <a:stretch>
+            <a:fillRect/>
+          </a:stretch>
+        </p:blipFill>
+        <p:spPr>
+          <a:xfrm>
+            <a:off x="3290862" y="0"/>
+            <a:ext cx="5610275" cy="6858000"/>
+          </a:xfrm>
+          <a:prstGeom prst="rect">
+            <a:avLst/>
+          </a:prstGeom>
+        </p:spPr>
+      </p:pic>
     </p:spTree>
     <p:extLst>
       <p:ext uri="{BB962C8B-B14F-4D97-AF65-F5344CB8AC3E}">
         <p14:creationId xmlns:p14="http://schemas.microsoft.com/office/powerpoint/2010/main" val="616314994"/>
+      </p:ext>
+    </p:extLst>
+  </p:cSld>
+  <p:clrMapOvr>
+    <a:masterClrMapping/>
+  </p:clrMapOvr>
+</p:sld>
+</file>
+
+<file path=ppt/slides/slide16.xml><?xml version="1.0" encoding="utf-8"?>
+<p:sld xmlns:a="http://schemas.openxmlformats.org/drawingml/2006/main" xmlns:r="http://schemas.openxmlformats.org/officeDocument/2006/relationships" xmlns:p="http://schemas.openxmlformats.org/presentationml/2006/main">
+  <p:cSld>
+    <p:spTree>
+      <p:nvGrpSpPr>
+        <p:cNvPr id="1" name="">
+          <a:extLst>
+            <a:ext uri="{FF2B5EF4-FFF2-40B4-BE49-F238E27FC236}">
+              <a16:creationId xmlns:a16="http://schemas.microsoft.com/office/drawing/2014/main" id="{EB1763E1-7A97-A469-2A0A-2725DA61EA54}"/>
+            </a:ext>
+          </a:extLst>
+        </p:cNvPr>
+        <p:cNvGrpSpPr/>
+        <p:nvPr/>
+      </p:nvGrpSpPr>
+      <p:grpSpPr>
+        <a:xfrm>
+          <a:off x="0" y="0"/>
+          <a:ext cx="0" cy="0"/>
+          <a:chOff x="0" y="0"/>
+          <a:chExt cx="0" cy="0"/>
+        </a:xfrm>
+      </p:grpSpPr>
+      <p:sp>
+        <p:nvSpPr>
+          <p:cNvPr id="3" name="TextBox 2">
+            <a:extLst>
+              <a:ext uri="{FF2B5EF4-FFF2-40B4-BE49-F238E27FC236}">
+                <a16:creationId xmlns:a16="http://schemas.microsoft.com/office/drawing/2014/main" id="{24F8C15F-6CD6-1CD6-7D20-6C2A627966EF}"/>
+              </a:ext>
+            </a:extLst>
+          </p:cNvPr>
+          <p:cNvSpPr txBox="1"/>
+          <p:nvPr/>
+        </p:nvSpPr>
+        <p:spPr>
+          <a:xfrm>
+            <a:off x="0" y="0"/>
+            <a:ext cx="12192000" cy="355354"/>
+          </a:xfrm>
+          <a:prstGeom prst="rect">
+            <a:avLst/>
+          </a:prstGeom>
+          <a:noFill/>
+        </p:spPr>
+        <p:txBody>
+          <a:bodyPr wrap="square">
+            <a:spAutoFit/>
+          </a:bodyPr>
+          <a:lstStyle/>
+          <a:p>
+            <a:pPr>
+              <a:lnSpc>
+                <a:spcPct val="150000"/>
+              </a:lnSpc>
+              <a:buNone/>
+            </a:pPr>
+            <a:r>
+              <a:rPr kumimoji="0" lang="en-US" altLang="en-US" sz="1300" b="0" i="0" u="none" strike="noStrike" cap="none" normalizeH="0" baseline="0">
+                <a:ln>
+                  <a:noFill/>
+                </a:ln>
+                <a:solidFill>
+                  <a:schemeClr val="tx1"/>
+                </a:solidFill>
+                <a:effectLst/>
+                <a:latin typeface="Arial" panose="020B0604020202020204" pitchFamily="34" charset="0"/>
+              </a:rPr>
+              <a:t>.</a:t>
+            </a:r>
+          </a:p>
+        </p:txBody>
+      </p:sp>
+      <p:pic>
+        <p:nvPicPr>
+          <p:cNvPr id="4" name="Picture 3">
+            <a:extLst>
+              <a:ext uri="{FF2B5EF4-FFF2-40B4-BE49-F238E27FC236}">
+                <a16:creationId xmlns:a16="http://schemas.microsoft.com/office/drawing/2014/main" id="{24D6CFA6-8FB2-E196-E8CE-922F2F83C9A4}"/>
+              </a:ext>
+            </a:extLst>
+          </p:cNvPr>
+          <p:cNvPicPr>
+            <a:picLocks noChangeAspect="1"/>
+          </p:cNvPicPr>
+          <p:nvPr/>
+        </p:nvPicPr>
+        <p:blipFill>
+          <a:blip r:embed="rId2"/>
+          <a:stretch>
+            <a:fillRect/>
+          </a:stretch>
+        </p:blipFill>
+        <p:spPr>
+          <a:xfrm>
+            <a:off x="0" y="471054"/>
+            <a:ext cx="5998322" cy="6386946"/>
+          </a:xfrm>
+          <a:prstGeom prst="rect">
+            <a:avLst/>
+          </a:prstGeom>
+        </p:spPr>
+      </p:pic>
+      <p:pic>
+        <p:nvPicPr>
+          <p:cNvPr id="6" name="Picture 5">
+            <a:extLst>
+              <a:ext uri="{FF2B5EF4-FFF2-40B4-BE49-F238E27FC236}">
+                <a16:creationId xmlns:a16="http://schemas.microsoft.com/office/drawing/2014/main" id="{526B6AB6-CD09-3D6B-07CC-C1DF363B30EA}"/>
+              </a:ext>
+            </a:extLst>
+          </p:cNvPr>
+          <p:cNvPicPr>
+            <a:picLocks noChangeAspect="1"/>
+          </p:cNvPicPr>
+          <p:nvPr/>
+        </p:nvPicPr>
+        <p:blipFill>
+          <a:blip r:embed="rId3"/>
+          <a:stretch>
+            <a:fillRect/>
+          </a:stretch>
+        </p:blipFill>
+        <p:spPr>
+          <a:xfrm>
+            <a:off x="6300298" y="471054"/>
+            <a:ext cx="5891701" cy="6386945"/>
+          </a:xfrm>
+          <a:prstGeom prst="rect">
+            <a:avLst/>
+          </a:prstGeom>
+        </p:spPr>
+      </p:pic>
+    </p:spTree>
+    <p:extLst>
+      <p:ext uri="{BB962C8B-B14F-4D97-AF65-F5344CB8AC3E}">
+        <p14:creationId xmlns:p14="http://schemas.microsoft.com/office/powerpoint/2010/main" val="3536907721"/>
+      </p:ext>
+    </p:extLst>
+  </p:cSld>
+  <p:clrMapOvr>
+    <a:masterClrMapping/>
+  </p:clrMapOvr>
+</p:sld>
+</file>
+
+<file path=ppt/slides/slide17.xml><?xml version="1.0" encoding="utf-8"?>
+<p:sld xmlns:a="http://schemas.openxmlformats.org/drawingml/2006/main" xmlns:r="http://schemas.openxmlformats.org/officeDocument/2006/relationships" xmlns:p="http://schemas.openxmlformats.org/presentationml/2006/main">
+  <p:cSld>
+    <p:spTree>
+      <p:nvGrpSpPr>
+        <p:cNvPr id="1" name="">
+          <a:extLst>
+            <a:ext uri="{FF2B5EF4-FFF2-40B4-BE49-F238E27FC236}">
+              <a16:creationId xmlns:a16="http://schemas.microsoft.com/office/drawing/2014/main" id="{7B5C7B75-8279-439D-40FC-EB84529B112C}"/>
+            </a:ext>
+          </a:extLst>
+        </p:cNvPr>
+        <p:cNvGrpSpPr/>
+        <p:nvPr/>
+      </p:nvGrpSpPr>
+      <p:grpSpPr>
+        <a:xfrm>
+          <a:off x="0" y="0"/>
+          <a:ext cx="0" cy="0"/>
+          <a:chOff x="0" y="0"/>
+          <a:chExt cx="0" cy="0"/>
+        </a:xfrm>
+      </p:grpSpPr>
+      <p:sp>
+        <p:nvSpPr>
+          <p:cNvPr id="3" name="TextBox 2">
+            <a:extLst>
+              <a:ext uri="{FF2B5EF4-FFF2-40B4-BE49-F238E27FC236}">
+                <a16:creationId xmlns:a16="http://schemas.microsoft.com/office/drawing/2014/main" id="{9D293982-FBAC-2987-A6BF-AF3EDD99FE3C}"/>
+              </a:ext>
+            </a:extLst>
+          </p:cNvPr>
+          <p:cNvSpPr txBox="1"/>
+          <p:nvPr/>
+        </p:nvSpPr>
+        <p:spPr>
+          <a:xfrm>
+            <a:off x="0" y="0"/>
+            <a:ext cx="12192000" cy="355354"/>
+          </a:xfrm>
+          <a:prstGeom prst="rect">
+            <a:avLst/>
+          </a:prstGeom>
+          <a:noFill/>
+        </p:spPr>
+        <p:txBody>
+          <a:bodyPr wrap="square">
+            <a:spAutoFit/>
+          </a:bodyPr>
+          <a:lstStyle/>
+          <a:p>
+            <a:pPr>
+              <a:lnSpc>
+                <a:spcPct val="150000"/>
+              </a:lnSpc>
+              <a:buNone/>
+            </a:pPr>
+            <a:r>
+              <a:rPr kumimoji="0" lang="en-US" altLang="en-US" sz="1300" b="0" i="0" u="none" strike="noStrike" cap="none" normalizeH="0" baseline="0">
+                <a:ln>
+                  <a:noFill/>
+                </a:ln>
+                <a:solidFill>
+                  <a:schemeClr val="tx1"/>
+                </a:solidFill>
+                <a:effectLst/>
+                <a:latin typeface="Arial" panose="020B0604020202020204" pitchFamily="34" charset="0"/>
+              </a:rPr>
+              <a:t>.</a:t>
+            </a:r>
+          </a:p>
+        </p:txBody>
+      </p:sp>
+      <p:pic>
+        <p:nvPicPr>
+          <p:cNvPr id="4" name="Picture 3">
+            <a:extLst>
+              <a:ext uri="{FF2B5EF4-FFF2-40B4-BE49-F238E27FC236}">
+                <a16:creationId xmlns:a16="http://schemas.microsoft.com/office/drawing/2014/main" id="{5BF83A5E-C6C0-5CC6-7AA7-7C44316E1D99}"/>
+              </a:ext>
+            </a:extLst>
+          </p:cNvPr>
+          <p:cNvPicPr>
+            <a:picLocks noChangeAspect="1"/>
+          </p:cNvPicPr>
+          <p:nvPr/>
+        </p:nvPicPr>
+        <p:blipFill>
+          <a:blip r:embed="rId2"/>
+          <a:stretch>
+            <a:fillRect/>
+          </a:stretch>
+        </p:blipFill>
+        <p:spPr>
+          <a:xfrm>
+            <a:off x="3638207" y="966444"/>
+            <a:ext cx="4915586" cy="4925112"/>
+          </a:xfrm>
+          <a:prstGeom prst="rect">
+            <a:avLst/>
+          </a:prstGeom>
+          <a:solidFill>
+            <a:srgbClr val="FFFFFF">
+              <a:shade val="85000"/>
+            </a:srgbClr>
+          </a:solidFill>
+          <a:ln w="88900" cap="sq">
+            <a:solidFill>
+              <a:srgbClr val="FFFFFF"/>
+            </a:solidFill>
+            <a:miter lim="800000"/>
+          </a:ln>
+          <a:effectLst>
+            <a:outerShdw blurRad="55000" dist="18000" dir="5400000" algn="tl" rotWithShape="0">
+              <a:srgbClr val="000000">
+                <a:alpha val="40000"/>
+              </a:srgbClr>
+            </a:outerShdw>
+          </a:effectLst>
+          <a:scene3d>
+            <a:camera prst="orthographicFront"/>
+            <a:lightRig rig="twoPt" dir="t">
+              <a:rot lat="0" lon="0" rev="7200000"/>
+            </a:lightRig>
+          </a:scene3d>
+          <a:sp3d>
+            <a:bevelT w="25400" h="19050"/>
+            <a:contourClr>
+              <a:srgbClr val="FFFFFF"/>
+            </a:contourClr>
+          </a:sp3d>
+        </p:spPr>
+      </p:pic>
+    </p:spTree>
+    <p:extLst>
+      <p:ext uri="{BB962C8B-B14F-4D97-AF65-F5344CB8AC3E}">
+        <p14:creationId xmlns:p14="http://schemas.microsoft.com/office/powerpoint/2010/main" val="1541270939"/>
+      </p:ext>
+    </p:extLst>
+  </p:cSld>
+  <p:clrMapOvr>
+    <a:masterClrMapping/>
+  </p:clrMapOvr>
+</p:sld>
+</file>
+
+<file path=ppt/slides/slide18.xml><?xml version="1.0" encoding="utf-8"?>
+<p:sld xmlns:a="http://schemas.openxmlformats.org/drawingml/2006/main" xmlns:r="http://schemas.openxmlformats.org/officeDocument/2006/relationships" xmlns:p="http://schemas.openxmlformats.org/presentationml/2006/main">
+  <p:cSld>
+    <p:spTree>
+      <p:nvGrpSpPr>
+        <p:cNvPr id="1" name="">
+          <a:extLst>
+            <a:ext uri="{FF2B5EF4-FFF2-40B4-BE49-F238E27FC236}">
+              <a16:creationId xmlns:a16="http://schemas.microsoft.com/office/drawing/2014/main" id="{78095DDA-69FE-83DD-14DA-6ABC8E4566E8}"/>
+            </a:ext>
+          </a:extLst>
+        </p:cNvPr>
+        <p:cNvGrpSpPr/>
+        <p:nvPr/>
+      </p:nvGrpSpPr>
+      <p:grpSpPr>
+        <a:xfrm>
+          <a:off x="0" y="0"/>
+          <a:ext cx="0" cy="0"/>
+          <a:chOff x="0" y="0"/>
+          <a:chExt cx="0" cy="0"/>
+        </a:xfrm>
+      </p:grpSpPr>
+      <p:sp>
+        <p:nvSpPr>
+          <p:cNvPr id="3" name="TextBox 2">
+            <a:extLst>
+              <a:ext uri="{FF2B5EF4-FFF2-40B4-BE49-F238E27FC236}">
+                <a16:creationId xmlns:a16="http://schemas.microsoft.com/office/drawing/2014/main" id="{735B480E-F36C-E4C4-875F-C0722113B4E7}"/>
+              </a:ext>
+            </a:extLst>
+          </p:cNvPr>
+          <p:cNvSpPr txBox="1"/>
+          <p:nvPr/>
+        </p:nvSpPr>
+        <p:spPr>
+          <a:xfrm>
+            <a:off x="0" y="0"/>
+            <a:ext cx="12192000" cy="355354"/>
+          </a:xfrm>
+          <a:prstGeom prst="rect">
+            <a:avLst/>
+          </a:prstGeom>
+          <a:noFill/>
+        </p:spPr>
+        <p:txBody>
+          <a:bodyPr wrap="square">
+            <a:spAutoFit/>
+          </a:bodyPr>
+          <a:lstStyle/>
+          <a:p>
+            <a:pPr>
+              <a:lnSpc>
+                <a:spcPct val="150000"/>
+              </a:lnSpc>
+              <a:buNone/>
+            </a:pPr>
+            <a:r>
+              <a:rPr kumimoji="0" lang="en-US" altLang="en-US" sz="1300" b="0" i="0" u="none" strike="noStrike" cap="none" normalizeH="0" baseline="0">
+                <a:ln>
+                  <a:noFill/>
+                </a:ln>
+                <a:solidFill>
+                  <a:schemeClr val="tx1"/>
+                </a:solidFill>
+                <a:effectLst/>
+                <a:latin typeface="Arial" panose="020B0604020202020204" pitchFamily="34" charset="0"/>
+              </a:rPr>
+              <a:t>.</a:t>
+            </a:r>
+          </a:p>
+        </p:txBody>
+      </p:sp>
+    </p:spTree>
+    <p:extLst>
+      <p:ext uri="{BB962C8B-B14F-4D97-AF65-F5344CB8AC3E}">
+        <p14:creationId xmlns:p14="http://schemas.microsoft.com/office/powerpoint/2010/main" val="2516926543"/>
+      </p:ext>
+    </p:extLst>
+  </p:cSld>
+  <p:clrMapOvr>
+    <a:masterClrMapping/>
+  </p:clrMapOvr>
+</p:sld>
+</file>
+
+<file path=ppt/slides/slide19.xml><?xml version="1.0" encoding="utf-8"?>
+<p:sld xmlns:a="http://schemas.openxmlformats.org/drawingml/2006/main" xmlns:r="http://schemas.openxmlformats.org/officeDocument/2006/relationships" xmlns:p="http://schemas.openxmlformats.org/presentationml/2006/main">
+  <p:cSld>
+    <p:spTree>
+      <p:nvGrpSpPr>
+        <p:cNvPr id="1" name="">
+          <a:extLst>
+            <a:ext uri="{FF2B5EF4-FFF2-40B4-BE49-F238E27FC236}">
+              <a16:creationId xmlns:a16="http://schemas.microsoft.com/office/drawing/2014/main" id="{6F175E99-E9D4-8721-5B32-EBA08E700B78}"/>
+            </a:ext>
+          </a:extLst>
+        </p:cNvPr>
+        <p:cNvGrpSpPr/>
+        <p:nvPr/>
+      </p:nvGrpSpPr>
+      <p:grpSpPr>
+        <a:xfrm>
+          <a:off x="0" y="0"/>
+          <a:ext cx="0" cy="0"/>
+          <a:chOff x="0" y="0"/>
+          <a:chExt cx="0" cy="0"/>
+        </a:xfrm>
+      </p:grpSpPr>
+      <p:sp>
+        <p:nvSpPr>
+          <p:cNvPr id="3" name="TextBox 2">
+            <a:extLst>
+              <a:ext uri="{FF2B5EF4-FFF2-40B4-BE49-F238E27FC236}">
+                <a16:creationId xmlns:a16="http://schemas.microsoft.com/office/drawing/2014/main" id="{EF6FF261-3D0C-BB3D-8A12-21C70F00C853}"/>
+              </a:ext>
+            </a:extLst>
+          </p:cNvPr>
+          <p:cNvSpPr txBox="1"/>
+          <p:nvPr/>
+        </p:nvSpPr>
+        <p:spPr>
+          <a:xfrm>
+            <a:off x="0" y="0"/>
+            <a:ext cx="12192000" cy="355354"/>
+          </a:xfrm>
+          <a:prstGeom prst="rect">
+            <a:avLst/>
+          </a:prstGeom>
+          <a:noFill/>
+        </p:spPr>
+        <p:txBody>
+          <a:bodyPr wrap="square">
+            <a:spAutoFit/>
+          </a:bodyPr>
+          <a:lstStyle/>
+          <a:p>
+            <a:pPr>
+              <a:lnSpc>
+                <a:spcPct val="150000"/>
+              </a:lnSpc>
+              <a:buNone/>
+            </a:pPr>
+            <a:r>
+              <a:rPr kumimoji="0" lang="en-US" altLang="en-US" sz="1300" b="0" i="0" u="none" strike="noStrike" cap="none" normalizeH="0" baseline="0">
+                <a:ln>
+                  <a:noFill/>
+                </a:ln>
+                <a:solidFill>
+                  <a:schemeClr val="tx1"/>
+                </a:solidFill>
+                <a:effectLst/>
+                <a:latin typeface="Arial" panose="020B0604020202020204" pitchFamily="34" charset="0"/>
+              </a:rPr>
+              <a:t>.</a:t>
+            </a:r>
+          </a:p>
+        </p:txBody>
+      </p:sp>
+    </p:spTree>
+    <p:extLst>
+      <p:ext uri="{BB962C8B-B14F-4D97-AF65-F5344CB8AC3E}">
+        <p14:creationId xmlns:p14="http://schemas.microsoft.com/office/powerpoint/2010/main" val="2091440927"/>
       </p:ext>
     </p:extLst>
   </p:cSld>

</xml_diff>